<commit_message>
feat: add Student/Institutional ID Card support and fix document detection misclassification
</commit_message>
<xml_diff>
--- a/PramaanSetu_SIH2026.pptx
+++ b/PramaanSetu_SIH2026.pptx
@@ -19,15 +19,15 @@
   <p:notesSz cx="6858000" cy="9144000"/>
   <p:embeddedFontLst>
     <p:embeddedFont>
-      <p:font typeface="Poppins" panose="020B0502040204020203" pitchFamily="2" charset="0"/>
+      <p:font typeface="Poppins" panose="00000500000000000000" pitchFamily="2" charset="0"/>
       <p:regular r:id="rId9"/>
     </p:embeddedFont>
     <p:embeddedFont>
-      <p:font typeface="Poppins Bold" panose="020B0604020202020204" charset="0"/>
+      <p:font typeface="Poppins Bold" panose="00000800000000000000" charset="0"/>
       <p:regular r:id="rId10"/>
     </p:embeddedFont>
     <p:embeddedFont>
-      <p:font typeface="Poppins Medium" panose="020B0502040204020203" pitchFamily="2" charset="0"/>
+      <p:font typeface="Poppins Medium" panose="00000600000000000000" pitchFamily="2" charset="0"/>
       <p:regular r:id="rId11"/>
     </p:embeddedFont>
     <p:embeddedFont>
@@ -4968,7 +4968,7 @@
               <a:buChar char="•"/>
             </a:pPr>
             <a:r>
-              <a:rPr lang="en-US" sz="2700">
+              <a:rPr lang="en-US" sz="2700" dirty="0">
                 <a:solidFill>
                   <a:srgbClr val="000000"/>
                 </a:solidFill>
@@ -7028,7 +7028,7 @@
               </a:lnSpc>
             </a:pPr>
             <a:r>
-              <a:rPr lang="en-US" sz="1551" b="1">
+              <a:rPr lang="en-US" sz="1551" b="1" dirty="0">
                 <a:solidFill>
                   <a:srgbClr val="002A5F"/>
                 </a:solidFill>
@@ -9387,7 +9387,7 @@
               </a:lnSpc>
             </a:pPr>
             <a:r>
-              <a:rPr lang="en-US" sz="1824" b="1">
+              <a:rPr lang="en-US" sz="1824" b="1" dirty="0">
                 <a:solidFill>
                   <a:srgbClr val="001548"/>
                 </a:solidFill>
@@ -9396,8 +9396,29 @@
                 <a:cs typeface="Poppins Bold"/>
                 <a:sym typeface="Poppins Bold"/>
               </a:rPr>
-              <a:t>Tesseract.js OCR, MRZ Parser, Field Extraction, jsQR</a:t>
-            </a:r>
+              <a:t>Tesseract.js OCR, MRZ Parser, Field Extraction, </a:t>
+            </a:r>
+            <a:r>
+              <a:rPr lang="en-US" sz="1824" b="1" dirty="0" err="1">
+                <a:solidFill>
+                  <a:srgbClr val="001548"/>
+                </a:solidFill>
+                <a:latin typeface="Poppins Bold"/>
+                <a:ea typeface="Poppins Bold"/>
+                <a:cs typeface="Poppins Bold"/>
+                <a:sym typeface="Poppins Bold"/>
+              </a:rPr>
+              <a:t>jsQR</a:t>
+            </a:r>
+            <a:endParaRPr lang="en-US" sz="1824" b="1" dirty="0">
+              <a:solidFill>
+                <a:srgbClr val="001548"/>
+              </a:solidFill>
+              <a:latin typeface="Poppins Bold"/>
+              <a:ea typeface="Poppins Bold"/>
+              <a:cs typeface="Poppins Bold"/>
+              <a:sym typeface="Poppins Bold"/>
+            </a:endParaRPr>
           </a:p>
         </p:txBody>
       </p:sp>
@@ -10185,7 +10206,7 @@
               </a:lnSpc>
             </a:pPr>
             <a:r>
-              <a:rPr lang="en-US" sz="1725" b="1">
+              <a:rPr lang="en-US" sz="1725" b="1" dirty="0">
                 <a:solidFill>
                   <a:srgbClr val="001548"/>
                 </a:solidFill>
@@ -10386,7 +10407,7 @@
         </p:nvSpPr>
         <p:spPr>
           <a:xfrm>
-            <a:off x="13307291" y="6800088"/>
+            <a:off x="13422734" y="6786869"/>
             <a:ext cx="2838450" cy="866775"/>
           </a:xfrm>
           <a:custGeom>
@@ -10423,6 +10444,13 @@
             </a:stretch>
           </a:blipFill>
         </p:spPr>
+        <p:txBody>
+          <a:bodyPr/>
+          <a:lstStyle/>
+          <a:p>
+            <a:endParaRPr lang="en-IN" dirty="0"/>
+          </a:p>
+        </p:txBody>
       </p:sp>
       <p:sp>
         <p:nvSpPr>

</xml_diff>